<commit_message>
updated the app to refer to the dbscan model
</commit_message>
<xml_diff>
--- a/presentation/Christopher_Lopez_Capstone_Business_Facing_Presentation.pptx
+++ b/presentation/Christopher_Lopez_Capstone_Business_Facing_Presentation.pptx
@@ -1715,7 +1715,7 @@
                 <a:ea typeface="Calibri" pitchFamily="34" charset="-122"/>
                 <a:cs typeface="Calibri" pitchFamily="34" charset="-120"/>
               </a:rPr>
-              <a:t>Capstone Project for the AIM Postgraduate Diploma in AI and Machine Learning</a:t>
+              <a:t>Capstone Project for the AIM Postgraduate Diploma in AI and Machine Learning – June 2026 – July 2026</a:t>
             </a:r>
           </a:p>
           <a:p>
@@ -3199,7 +3199,7 @@
                 </a:solidFill>
                 <a:latin typeface="Calibri" pitchFamily="34" charset="0"/>
               </a:rPr>
-              <a:t>Prepared by Christopher Lopez   |   AIM Post Graduate Diploma in AI and Machine Learning</a:t>
+              <a:t>Prepared by Christopher Lopez   |   AIM Post Graduate Diploma in AI and Machine Learning – June 2025 –July 2026</a:t>
             </a:r>
             <a:endParaRPr lang="en-US" sz="1050" dirty="0"/>
           </a:p>
@@ -3469,7 +3469,7 @@
                 <a:ea typeface="Calibri" pitchFamily="34" charset="-122"/>
                 <a:cs typeface="Calibri" pitchFamily="34" charset="-120"/>
               </a:rPr>
-              <a:t>Most maintenance is reactive — teams fix machines after something breaks, rather than catching warning signs early.</a:t>
+              <a:t>Most maintenance is reactive, teams fix machines after something breaks, rather than catching warning signs early.</a:t>
             </a:r>
             <a:endParaRPr lang="en-US" sz="1450" dirty="0"/>
           </a:p>
@@ -4730,6 +4730,56 @@
           </a:p>
         </p:txBody>
       </p:sp>
+      <p:sp>
+        <p:nvSpPr>
+          <p:cNvPr id="29" name="TextBox 28">
+            <a:extLst>
+              <a:ext uri="{FF2B5EF4-FFF2-40B4-BE49-F238E27FC236}">
+                <a16:creationId xmlns:a16="http://schemas.microsoft.com/office/drawing/2014/main" id="{23AA4AA2-BA88-C1FD-A4CA-E9E512FF65BF}"/>
+              </a:ext>
+            </a:extLst>
+          </p:cNvPr>
+          <p:cNvSpPr txBox="1"/>
+          <p:nvPr/>
+        </p:nvSpPr>
+        <p:spPr>
+          <a:xfrm>
+            <a:off x="323088" y="6388084"/>
+            <a:ext cx="10590196" cy="307777"/>
+          </a:xfrm>
+          <a:prstGeom prst="rect">
+            <a:avLst/>
+          </a:prstGeom>
+          <a:noFill/>
+        </p:spPr>
+        <p:txBody>
+          <a:bodyPr wrap="square" rtlCol="0">
+            <a:spAutoFit/>
+          </a:bodyPr>
+          <a:lstStyle/>
+          <a:p>
+            <a:r>
+              <a:rPr lang="en-US" sz="1400" b="1" dirty="0"/>
+              <a:t>Source:</a:t>
+            </a:r>
+            <a:r>
+              <a:rPr lang="en-US" sz="1400" dirty="0"/>
+              <a:t> </a:t>
+            </a:r>
+            <a:r>
+              <a:rPr lang="en-US" sz="1400" dirty="0">
+                <a:hlinkClick r:id="rId8"/>
+              </a:rPr>
+              <a:t>https://www.kaggle.com/datasets/stephanmatzka/predictive-maintenance-dataset-ai4i-2020</a:t>
+            </a:r>
+            <a:r>
+              <a:rPr lang="en-US" sz="1400" dirty="0"/>
+              <a:t> </a:t>
+            </a:r>
+            <a:endParaRPr lang="en-PH" sz="1400" dirty="0"/>
+          </a:p>
+        </p:txBody>
+      </p:sp>
     </p:spTree>
   </p:cSld>
   <p:clrMapOvr>
@@ -5039,10 +5089,10 @@
       </p:sp>
       <p:pic>
         <p:nvPicPr>
-          <p:cNvPr id="13" name="Picture 12">
+          <p:cNvPr id="9" name="Picture 8">
             <a:extLst>
               <a:ext uri="{FF2B5EF4-FFF2-40B4-BE49-F238E27FC236}">
-                <a16:creationId xmlns:a16="http://schemas.microsoft.com/office/drawing/2014/main" id="{BF559ADE-2D4B-94DB-6BB4-339705F5754E}"/>
+                <a16:creationId xmlns:a16="http://schemas.microsoft.com/office/drawing/2014/main" id="{04A2BB6F-A9B6-553D-4F9C-BA539C7683A2}"/>
               </a:ext>
             </a:extLst>
           </p:cNvPr>
@@ -5059,12 +5109,17 @@
         </p:blipFill>
         <p:spPr>
           <a:xfrm>
-            <a:off x="948657" y="3924110"/>
-            <a:ext cx="9848062" cy="2751010"/>
-          </a:xfrm>
-          <a:prstGeom prst="rect">
-            <a:avLst/>
-          </a:prstGeom>
+            <a:off x="1140989" y="3936535"/>
+            <a:ext cx="10056398" cy="2809209"/>
+          </a:xfrm>
+          <a:prstGeom prst="rect">
+            <a:avLst/>
+          </a:prstGeom>
+          <a:ln w="3175">
+            <a:solidFill>
+              <a:schemeClr val="tx1"/>
+            </a:solidFill>
+          </a:ln>
         </p:spPr>
       </p:pic>
     </p:spTree>
@@ -5347,7 +5402,7 @@
                 <a:ea typeface="Calibri" pitchFamily="34" charset="-122"/>
                 <a:cs typeface="Calibri" pitchFamily="34" charset="-120"/>
               </a:rPr>
-              <a:t>The clearest, most interpretable result came from K-Means, organizing machines into four distinct operating states.</a:t>
+              <a:t>The clearest, most interpretable result came from DBSCAN, organizing machines into 3 operating states or clusters.</a:t>
             </a:r>
             <a:endParaRPr lang="en-US" sz="1450" dirty="0"/>
           </a:p>
@@ -6076,7 +6131,7 @@
                 <a:ea typeface="Cambria" pitchFamily="34" charset="-122"/>
                 <a:cs typeface="Cambria" pitchFamily="34" charset="-120"/>
               </a:rPr>
-              <a:t>Four Machine Behavior Profiles</a:t>
+              <a:t>3 Machine Behavior Profiles</a:t>
             </a:r>
             <a:endParaRPr lang="en-US" sz="2700" dirty="0"/>
           </a:p>
@@ -6129,7 +6184,7 @@
         </p:nvSpPr>
         <p:spPr>
           <a:xfrm>
-            <a:off x="548640" y="1600200"/>
+            <a:off x="1908207" y="1600200"/>
             <a:ext cx="2697480" cy="4480560"/>
           </a:xfrm>
           <a:prstGeom prst="roundRect">
@@ -6165,7 +6220,7 @@
         </p:nvSpPr>
         <p:spPr>
           <a:xfrm>
-            <a:off x="1531620" y="1920240"/>
+            <a:off x="2891187" y="1920240"/>
             <a:ext cx="731520" cy="731520"/>
           </a:xfrm>
           <a:prstGeom prst="ellipse">
@@ -6200,7 +6255,7 @@
         </p:blipFill>
         <p:spPr>
           <a:xfrm>
-            <a:off x="1619402" y="2008022"/>
+            <a:off x="2978969" y="2008022"/>
             <a:ext cx="555955" cy="555955"/>
           </a:xfrm>
           <a:prstGeom prst="rect">
@@ -6216,7 +6271,7 @@
         </p:nvSpPr>
         <p:spPr>
           <a:xfrm>
-            <a:off x="548640" y="2834640"/>
+            <a:off x="1908207" y="2834640"/>
             <a:ext cx="2697480" cy="274320"/>
           </a:xfrm>
           <a:prstGeom prst="rect">
@@ -6255,7 +6310,7 @@
         </p:nvSpPr>
         <p:spPr>
           <a:xfrm>
-            <a:off x="685800" y="3108960"/>
+            <a:off x="2045367" y="3108960"/>
             <a:ext cx="2423160" cy="640080"/>
           </a:xfrm>
           <a:prstGeom prst="rect">
@@ -6280,7 +6335,7 @@
                 <a:ea typeface="Cambria" pitchFamily="34" charset="-122"/>
                 <a:cs typeface="Cambria" pitchFamily="34" charset="-120"/>
               </a:rPr>
-              <a:t>Stable Operators</a:t>
+              <a:t>Variable Operation</a:t>
             </a:r>
             <a:endParaRPr lang="en-US" sz="1600" dirty="0"/>
           </a:p>
@@ -6294,7 +6349,7 @@
         </p:nvSpPr>
         <p:spPr>
           <a:xfrm>
-            <a:off x="914400" y="3840480"/>
+            <a:off x="2273967" y="3840480"/>
             <a:ext cx="1965960" cy="0"/>
           </a:xfrm>
           <a:prstGeom prst="line">
@@ -6324,7 +6379,7 @@
         </p:nvSpPr>
         <p:spPr>
           <a:xfrm>
-            <a:off x="731520" y="3977640"/>
+            <a:off x="2091087" y="3977640"/>
             <a:ext cx="2331720" cy="914400"/>
           </a:xfrm>
           <a:prstGeom prst="rect">
@@ -6337,49 +6392,40 @@
           <a:bodyPr wrap="square" lIns="0" tIns="0" rIns="0" bIns="0" rtlCol="0" anchor="ctr"/>
           <a:lstStyle/>
           <a:p>
+            <a:pPr algn="ctr"/>
+            <a:r>
+              <a:rPr lang="en-PH" sz="1200" dirty="0"/>
+              <a:t>Operating normally with some variability</a:t>
+            </a:r>
+            <a:endParaRPr lang="en-US" sz="1200" dirty="0"/>
+          </a:p>
+        </p:txBody>
+      </p:sp>
+      <p:sp>
+        <p:nvSpPr>
+          <p:cNvPr id="14" name="Text 10"/>
+          <p:cNvSpPr/>
+          <p:nvPr/>
+        </p:nvSpPr>
+        <p:spPr>
+          <a:xfrm>
+            <a:off x="2091087" y="5029200"/>
+            <a:ext cx="2331720" cy="868680"/>
+          </a:xfrm>
+          <a:prstGeom prst="rect">
+            <a:avLst/>
+          </a:prstGeom>
+          <a:noFill/>
+          <a:ln/>
+        </p:spPr>
+        <p:txBody>
+          <a:bodyPr wrap="square" lIns="0" tIns="0" rIns="0" bIns="0" rtlCol="0" anchor="ctr"/>
+          <a:lstStyle/>
+          <a:p>
             <a:pPr marL="0" indent="0" algn="ctr">
               <a:buNone/>
             </a:pPr>
             <a:r>
-              <a:rPr lang="en-US" sz="1150" dirty="0">
-                <a:solidFill>
-                  <a:srgbClr val="5B6B72"/>
-                </a:solidFill>
-                <a:latin typeface="Calibri" pitchFamily="34" charset="0"/>
-                <a:ea typeface="Calibri" pitchFamily="34" charset="-122"/>
-                <a:cs typeface="Calibri" pitchFamily="34" charset="-120"/>
-              </a:rPr>
-              <a:t>Running smoothly under normal load</a:t>
-            </a:r>
-            <a:endParaRPr lang="en-US" sz="1150" dirty="0"/>
-          </a:p>
-        </p:txBody>
-      </p:sp>
-      <p:sp>
-        <p:nvSpPr>
-          <p:cNvPr id="14" name="Text 10"/>
-          <p:cNvSpPr/>
-          <p:nvPr/>
-        </p:nvSpPr>
-        <p:spPr>
-          <a:xfrm>
-            <a:off x="731520" y="5029200"/>
-            <a:ext cx="2331720" cy="868680"/>
-          </a:xfrm>
-          <a:prstGeom prst="rect">
-            <a:avLst/>
-          </a:prstGeom>
-          <a:noFill/>
-          <a:ln/>
-        </p:spPr>
-        <p:txBody>
-          <a:bodyPr wrap="square" lIns="0" tIns="0" rIns="0" bIns="0" rtlCol="0" anchor="ctr"/>
-          <a:lstStyle/>
-          <a:p>
-            <a:pPr marL="0" indent="0" algn="ctr">
-              <a:buNone/>
-            </a:pPr>
-            <a:r>
               <a:rPr lang="en-US" sz="1200" b="1" dirty="0">
                 <a:solidFill>
                   <a:srgbClr val="3D8361"/>
@@ -6402,7 +6448,7 @@
         </p:nvSpPr>
         <p:spPr>
           <a:xfrm>
-            <a:off x="3474720" y="1600200"/>
+            <a:off x="4834287" y="1600200"/>
             <a:ext cx="2697480" cy="4480560"/>
           </a:xfrm>
           <a:prstGeom prst="roundRect">
@@ -6438,7 +6484,7 @@
         </p:nvSpPr>
         <p:spPr>
           <a:xfrm>
-            <a:off x="4457700" y="1920240"/>
+            <a:off x="5817267" y="1920240"/>
             <a:ext cx="731520" cy="731520"/>
           </a:xfrm>
           <a:prstGeom prst="ellipse">
@@ -6473,7 +6519,7 @@
         </p:blipFill>
         <p:spPr>
           <a:xfrm>
-            <a:off x="4545482" y="2008022"/>
+            <a:off x="5905049" y="2008022"/>
             <a:ext cx="555955" cy="555955"/>
           </a:xfrm>
           <a:prstGeom prst="rect">
@@ -6489,7 +6535,7 @@
         </p:nvSpPr>
         <p:spPr>
           <a:xfrm>
-            <a:off x="3474720" y="2834640"/>
+            <a:off x="4834287" y="2834640"/>
             <a:ext cx="2697480" cy="274320"/>
           </a:xfrm>
           <a:prstGeom prst="rect">
@@ -6528,7 +6574,7 @@
         </p:nvSpPr>
         <p:spPr>
           <a:xfrm>
-            <a:off x="3611880" y="3108960"/>
+            <a:off x="4971447" y="3108960"/>
             <a:ext cx="2423160" cy="640080"/>
           </a:xfrm>
           <a:prstGeom prst="rect">
@@ -6553,7 +6599,7 @@
                 <a:ea typeface="Cambria" pitchFamily="34" charset="-122"/>
                 <a:cs typeface="Cambria" pitchFamily="34" charset="-120"/>
               </a:rPr>
-              <a:t>Efficient / Young</a:t>
+              <a:t>Stable</a:t>
             </a:r>
             <a:endParaRPr lang="en-US" sz="1600" dirty="0"/>
           </a:p>
@@ -6567,7 +6613,7 @@
         </p:nvSpPr>
         <p:spPr>
           <a:xfrm>
-            <a:off x="3840480" y="3840480"/>
+            <a:off x="5200047" y="3840480"/>
             <a:ext cx="1965960" cy="0"/>
           </a:xfrm>
           <a:prstGeom prst="line">
@@ -6597,7 +6643,7 @@
         </p:nvSpPr>
         <p:spPr>
           <a:xfrm>
-            <a:off x="3657600" y="3977640"/>
+            <a:off x="5017167" y="3977640"/>
             <a:ext cx="2331720" cy="914400"/>
           </a:xfrm>
           <a:prstGeom prst="rect">
@@ -6622,7 +6668,7 @@
                 <a:ea typeface="Calibri" pitchFamily="34" charset="-122"/>
                 <a:cs typeface="Calibri" pitchFamily="34" charset="-120"/>
               </a:rPr>
-              <a:t>Newer or recently serviced units</a:t>
+              <a:t>Optimal operating condition</a:t>
             </a:r>
             <a:endParaRPr lang="en-US" sz="1150" dirty="0"/>
           </a:p>
@@ -6636,7 +6682,7 @@
         </p:nvSpPr>
         <p:spPr>
           <a:xfrm>
-            <a:off x="3657600" y="5029200"/>
+            <a:off x="5017167" y="5029200"/>
             <a:ext cx="2331720" cy="868680"/>
           </a:xfrm>
           <a:prstGeom prst="rect">
@@ -6669,13 +6715,13 @@
       </p:sp>
       <p:sp>
         <p:nvSpPr>
-          <p:cNvPr id="23" name="Shape 18"/>
-          <p:cNvSpPr/>
-          <p:nvPr/>
-        </p:nvSpPr>
-        <p:spPr>
-          <a:xfrm>
-            <a:off x="6400800" y="1600200"/>
+          <p:cNvPr id="31" name="Shape 25"/>
+          <p:cNvSpPr/>
+          <p:nvPr/>
+        </p:nvSpPr>
+        <p:spPr>
+          <a:xfrm>
+            <a:off x="7786828" y="1600200"/>
             <a:ext cx="2697480" cy="4480560"/>
           </a:xfrm>
           <a:prstGeom prst="roundRect">
@@ -6705,20 +6751,20 @@
       </p:sp>
       <p:sp>
         <p:nvSpPr>
-          <p:cNvPr id="24" name="Shape 19"/>
-          <p:cNvSpPr/>
-          <p:nvPr/>
-        </p:nvSpPr>
-        <p:spPr>
-          <a:xfrm>
-            <a:off x="7383780" y="1920240"/>
+          <p:cNvPr id="32" name="Shape 26"/>
+          <p:cNvSpPr/>
+          <p:nvPr/>
+        </p:nvSpPr>
+        <p:spPr>
+          <a:xfrm>
+            <a:off x="8769808" y="1920240"/>
             <a:ext cx="731520" cy="731520"/>
           </a:xfrm>
           <a:prstGeom prst="ellipse">
             <a:avLst/>
           </a:prstGeom>
           <a:solidFill>
-            <a:srgbClr val="D6870A"/>
+            <a:srgbClr val="C1440E"/>
           </a:solidFill>
           <a:ln/>
         </p:spPr>
@@ -6732,7 +6778,7 @@
       </p:sp>
       <p:pic>
         <p:nvPicPr>
-          <p:cNvPr id="25" name="Image 3" descr="preencoded.png"/>
+          <p:cNvPr id="33" name="Image 4" descr="preencoded.png"/>
           <p:cNvPicPr>
             <a:picLocks noChangeAspect="1"/>
           </p:cNvPicPr>
@@ -6746,7 +6792,7 @@
         </p:blipFill>
         <p:spPr>
           <a:xfrm>
-            <a:off x="7471562" y="2008022"/>
+            <a:off x="8857590" y="2008022"/>
             <a:ext cx="555955" cy="555955"/>
           </a:xfrm>
           <a:prstGeom prst="rect">
@@ -6756,13 +6802,13 @@
       </p:pic>
       <p:sp>
         <p:nvSpPr>
-          <p:cNvPr id="26" name="Text 20"/>
-          <p:cNvSpPr/>
-          <p:nvPr/>
-        </p:nvSpPr>
-        <p:spPr>
-          <a:xfrm>
-            <a:off x="6400800" y="2834640"/>
+          <p:cNvPr id="34" name="Text 27"/>
+          <p:cNvSpPr/>
+          <p:nvPr/>
+        </p:nvSpPr>
+        <p:spPr>
+          <a:xfrm>
+            <a:off x="7786828" y="2834640"/>
             <a:ext cx="2697480" cy="274320"/>
           </a:xfrm>
           <a:prstGeom prst="rect">
@@ -6787,7 +6833,7 @@
                 <a:ea typeface="Calibri" pitchFamily="34" charset="-122"/>
                 <a:cs typeface="Calibri" pitchFamily="34" charset="-120"/>
               </a:rPr>
-              <a:t>Cluster 2</a:t>
+              <a:t>Cluster -1</a:t>
             </a:r>
             <a:endParaRPr lang="en-US" sz="1100" dirty="0"/>
           </a:p>
@@ -6795,13 +6841,13 @@
       </p:sp>
       <p:sp>
         <p:nvSpPr>
-          <p:cNvPr id="27" name="Text 21"/>
-          <p:cNvSpPr/>
-          <p:nvPr/>
-        </p:nvSpPr>
-        <p:spPr>
-          <a:xfrm>
-            <a:off x="6537960" y="3108960"/>
+          <p:cNvPr id="35" name="Text 28"/>
+          <p:cNvSpPr/>
+          <p:nvPr/>
+        </p:nvSpPr>
+        <p:spPr>
+          <a:xfrm>
+            <a:off x="7923988" y="3108960"/>
             <a:ext cx="2423160" cy="640080"/>
           </a:xfrm>
           <a:prstGeom prst="rect">
@@ -6826,7 +6872,7 @@
                 <a:ea typeface="Cambria" pitchFamily="34" charset="-122"/>
                 <a:cs typeface="Cambria" pitchFamily="34" charset="-120"/>
               </a:rPr>
-              <a:t>High-Load Machines</a:t>
+              <a:t>Abnormal Load</a:t>
             </a:r>
             <a:endParaRPr lang="en-US" sz="1600" dirty="0"/>
           </a:p>
@@ -6834,13 +6880,13 @@
       </p:sp>
       <p:sp>
         <p:nvSpPr>
-          <p:cNvPr id="28" name="Shape 22"/>
-          <p:cNvSpPr/>
-          <p:nvPr/>
-        </p:nvSpPr>
-        <p:spPr>
-          <a:xfrm>
-            <a:off x="6766560" y="3840480"/>
+          <p:cNvPr id="36" name="Shape 29"/>
+          <p:cNvSpPr/>
+          <p:nvPr/>
+        </p:nvSpPr>
+        <p:spPr>
+          <a:xfrm>
+            <a:off x="8152588" y="3840480"/>
             <a:ext cx="1965960" cy="0"/>
           </a:xfrm>
           <a:prstGeom prst="line">
@@ -6864,13 +6910,13 @@
       </p:sp>
       <p:sp>
         <p:nvSpPr>
-          <p:cNvPr id="29" name="Text 23"/>
-          <p:cNvSpPr/>
-          <p:nvPr/>
-        </p:nvSpPr>
-        <p:spPr>
-          <a:xfrm>
-            <a:off x="6583680" y="3977640"/>
+          <p:cNvPr id="37" name="Text 30"/>
+          <p:cNvSpPr/>
+          <p:nvPr/>
+        </p:nvSpPr>
+        <p:spPr>
+          <a:xfrm>
+            <a:off x="7969708" y="3977640"/>
             <a:ext cx="2331720" cy="914400"/>
           </a:xfrm>
           <a:prstGeom prst="rect">
@@ -6895,7 +6941,7 @@
                 <a:ea typeface="Calibri" pitchFamily="34" charset="-122"/>
                 <a:cs typeface="Calibri" pitchFamily="34" charset="-120"/>
               </a:rPr>
-              <a:t>Working hard, elevated temperature</a:t>
+              <a:t>Signs of failure or worth investigating for maintenance</a:t>
             </a:r>
             <a:endParaRPr lang="en-US" sz="1150" dirty="0"/>
           </a:p>
@@ -6903,286 +6949,13 @@
       </p:sp>
       <p:sp>
         <p:nvSpPr>
-          <p:cNvPr id="30" name="Text 24"/>
-          <p:cNvSpPr/>
-          <p:nvPr/>
-        </p:nvSpPr>
-        <p:spPr>
-          <a:xfrm>
-            <a:off x="6583680" y="5029200"/>
-            <a:ext cx="2331720" cy="868680"/>
-          </a:xfrm>
-          <a:prstGeom prst="rect">
-            <a:avLst/>
-          </a:prstGeom>
-          <a:noFill/>
-          <a:ln/>
-        </p:spPr>
-        <p:txBody>
-          <a:bodyPr wrap="square" lIns="0" tIns="0" rIns="0" bIns="0" rtlCol="0" anchor="ctr"/>
-          <a:lstStyle/>
-          <a:p>
-            <a:pPr marL="0" indent="0" algn="ctr">
-              <a:buNone/>
-            </a:pPr>
-            <a:r>
-              <a:rPr lang="en-US" sz="1200" b="1" dirty="0">
-                <a:solidFill>
-                  <a:srgbClr val="D6870A"/>
-                </a:solidFill>
-                <a:latin typeface="Calibri" pitchFamily="34" charset="0"/>
-                <a:ea typeface="Calibri" pitchFamily="34" charset="-122"/>
-                <a:cs typeface="Calibri" pitchFamily="34" charset="-120"/>
-              </a:rPr>
-              <a:t>Schedule preventive checks</a:t>
-            </a:r>
-            <a:endParaRPr lang="en-US" sz="1200" dirty="0"/>
-          </a:p>
-        </p:txBody>
-      </p:sp>
-      <p:sp>
-        <p:nvSpPr>
-          <p:cNvPr id="31" name="Shape 25"/>
-          <p:cNvSpPr/>
-          <p:nvPr/>
-        </p:nvSpPr>
-        <p:spPr>
-          <a:xfrm>
-            <a:off x="9326880" y="1600200"/>
-            <a:ext cx="2697480" cy="4480560"/>
-          </a:xfrm>
-          <a:prstGeom prst="roundRect">
-            <a:avLst>
-              <a:gd name="adj" fmla="val 4068"/>
-            </a:avLst>
-          </a:prstGeom>
-          <a:solidFill>
-            <a:srgbClr val="FFFFFF"/>
-          </a:solidFill>
-          <a:ln/>
-          <a:effectLst>
-            <a:outerShdw blurRad="101600" dist="38100" dir="5400000" algn="bl" rotWithShape="0">
-              <a:srgbClr val="000000">
-                <a:alpha val="12000"/>
-              </a:srgbClr>
-            </a:outerShdw>
-          </a:effectLst>
-        </p:spPr>
-        <p:txBody>
-          <a:bodyPr/>
-          <a:lstStyle/>
-          <a:p>
-            <a:endParaRPr lang="en-PH"/>
-          </a:p>
-        </p:txBody>
-      </p:sp>
-      <p:sp>
-        <p:nvSpPr>
-          <p:cNvPr id="32" name="Shape 26"/>
-          <p:cNvSpPr/>
-          <p:nvPr/>
-        </p:nvSpPr>
-        <p:spPr>
-          <a:xfrm>
-            <a:off x="10309860" y="1920240"/>
-            <a:ext cx="731520" cy="731520"/>
-          </a:xfrm>
-          <a:prstGeom prst="ellipse">
-            <a:avLst/>
-          </a:prstGeom>
-          <a:solidFill>
-            <a:srgbClr val="C1440E"/>
-          </a:solidFill>
-          <a:ln/>
-        </p:spPr>
-        <p:txBody>
-          <a:bodyPr/>
-          <a:lstStyle/>
-          <a:p>
-            <a:endParaRPr lang="en-PH"/>
-          </a:p>
-        </p:txBody>
-      </p:sp>
-      <p:pic>
-        <p:nvPicPr>
-          <p:cNvPr id="33" name="Image 4" descr="preencoded.png"/>
-          <p:cNvPicPr>
-            <a:picLocks noChangeAspect="1"/>
-          </p:cNvPicPr>
-          <p:nvPr/>
-        </p:nvPicPr>
-        <p:blipFill>
-          <a:blip r:embed="rId6"/>
-          <a:stretch>
-            <a:fillRect/>
-          </a:stretch>
-        </p:blipFill>
-        <p:spPr>
-          <a:xfrm>
-            <a:off x="10397642" y="2008022"/>
-            <a:ext cx="555955" cy="555955"/>
-          </a:xfrm>
-          <a:prstGeom prst="rect">
-            <a:avLst/>
-          </a:prstGeom>
-        </p:spPr>
-      </p:pic>
-      <p:sp>
-        <p:nvSpPr>
-          <p:cNvPr id="34" name="Text 27"/>
-          <p:cNvSpPr/>
-          <p:nvPr/>
-        </p:nvSpPr>
-        <p:spPr>
-          <a:xfrm>
-            <a:off x="9326880" y="2834640"/>
-            <a:ext cx="2697480" cy="274320"/>
-          </a:xfrm>
-          <a:prstGeom prst="rect">
-            <a:avLst/>
-          </a:prstGeom>
-          <a:noFill/>
-          <a:ln/>
-        </p:spPr>
-        <p:txBody>
-          <a:bodyPr wrap="square" lIns="0" tIns="0" rIns="0" bIns="0" rtlCol="0" anchor="ctr"/>
-          <a:lstStyle/>
-          <a:p>
-            <a:pPr marL="0" indent="0" algn="ctr">
-              <a:buNone/>
-            </a:pPr>
-            <a:r>
-              <a:rPr lang="en-US" sz="1100" b="1" kern="0" spc="100" dirty="0">
-                <a:solidFill>
-                  <a:srgbClr val="5B6B72"/>
-                </a:solidFill>
-                <a:latin typeface="Calibri" pitchFamily="34" charset="0"/>
-                <a:ea typeface="Calibri" pitchFamily="34" charset="-122"/>
-                <a:cs typeface="Calibri" pitchFamily="34" charset="-120"/>
-              </a:rPr>
-              <a:t>Cluster 3</a:t>
-            </a:r>
-            <a:endParaRPr lang="en-US" sz="1100" dirty="0"/>
-          </a:p>
-        </p:txBody>
-      </p:sp>
-      <p:sp>
-        <p:nvSpPr>
-          <p:cNvPr id="35" name="Text 28"/>
-          <p:cNvSpPr/>
-          <p:nvPr/>
-        </p:nvSpPr>
-        <p:spPr>
-          <a:xfrm>
-            <a:off x="9464040" y="3108960"/>
-            <a:ext cx="2423160" cy="640080"/>
-          </a:xfrm>
-          <a:prstGeom prst="rect">
-            <a:avLst/>
-          </a:prstGeom>
-          <a:noFill/>
-          <a:ln/>
-        </p:spPr>
-        <p:txBody>
-          <a:bodyPr wrap="square" lIns="0" tIns="0" rIns="0" bIns="0" rtlCol="0" anchor="ctr"/>
-          <a:lstStyle/>
-          <a:p>
-            <a:pPr marL="0" indent="0" algn="ctr">
-              <a:buNone/>
-            </a:pPr>
-            <a:r>
-              <a:rPr lang="en-US" sz="1600" b="1" dirty="0">
-                <a:solidFill>
-                  <a:srgbClr val="1F2B33"/>
-                </a:solidFill>
-                <a:latin typeface="Cambria" pitchFamily="34" charset="0"/>
-                <a:ea typeface="Cambria" pitchFamily="34" charset="-122"/>
-                <a:cs typeface="Cambria" pitchFamily="34" charset="-120"/>
-              </a:rPr>
-              <a:t>Aging / At-Risk</a:t>
-            </a:r>
-            <a:endParaRPr lang="en-US" sz="1600" dirty="0"/>
-          </a:p>
-        </p:txBody>
-      </p:sp>
-      <p:sp>
-        <p:nvSpPr>
-          <p:cNvPr id="36" name="Shape 29"/>
-          <p:cNvSpPr/>
-          <p:nvPr/>
-        </p:nvSpPr>
-        <p:spPr>
-          <a:xfrm>
-            <a:off x="9692640" y="3840480"/>
-            <a:ext cx="1965960" cy="0"/>
-          </a:xfrm>
-          <a:prstGeom prst="line">
-            <a:avLst/>
-          </a:prstGeom>
-          <a:noFill/>
-          <a:ln w="12700">
-            <a:solidFill>
-              <a:srgbClr val="E2E6E7"/>
-            </a:solidFill>
-            <a:prstDash val="solid"/>
-          </a:ln>
-        </p:spPr>
-        <p:txBody>
-          <a:bodyPr/>
-          <a:lstStyle/>
-          <a:p>
-            <a:endParaRPr lang="en-PH"/>
-          </a:p>
-        </p:txBody>
-      </p:sp>
-      <p:sp>
-        <p:nvSpPr>
-          <p:cNvPr id="37" name="Text 30"/>
-          <p:cNvSpPr/>
-          <p:nvPr/>
-        </p:nvSpPr>
-        <p:spPr>
-          <a:xfrm>
-            <a:off x="9509760" y="3977640"/>
-            <a:ext cx="2331720" cy="914400"/>
-          </a:xfrm>
-          <a:prstGeom prst="rect">
-            <a:avLst/>
-          </a:prstGeom>
-          <a:noFill/>
-          <a:ln/>
-        </p:spPr>
-        <p:txBody>
-          <a:bodyPr wrap="square" lIns="0" tIns="0" rIns="0" bIns="0" rtlCol="0" anchor="ctr"/>
-          <a:lstStyle/>
-          <a:p>
-            <a:pPr marL="0" indent="0" algn="ctr">
-              <a:buNone/>
-            </a:pPr>
-            <a:r>
-              <a:rPr lang="en-US" sz="1150" dirty="0">
-                <a:solidFill>
-                  <a:srgbClr val="5B6B72"/>
-                </a:solidFill>
-                <a:latin typeface="Calibri" pitchFamily="34" charset="0"/>
-                <a:ea typeface="Calibri" pitchFamily="34" charset="-122"/>
-                <a:cs typeface="Calibri" pitchFamily="34" charset="-120"/>
-              </a:rPr>
-              <a:t>High wear, rising temperature</a:t>
-            </a:r>
-            <a:endParaRPr lang="en-US" sz="1150" dirty="0"/>
-          </a:p>
-        </p:txBody>
-      </p:sp>
-      <p:sp>
-        <p:nvSpPr>
           <p:cNvPr id="38" name="Text 31"/>
           <p:cNvSpPr/>
           <p:nvPr/>
         </p:nvSpPr>
         <p:spPr>
           <a:xfrm>
-            <a:off x="9509760" y="5029200"/>
+            <a:off x="7969708" y="5029200"/>
             <a:ext cx="2331720" cy="868680"/>
           </a:xfrm>
           <a:prstGeom prst="rect">

</xml_diff>

<commit_message>
updated the presentation files
</commit_message>
<xml_diff>
--- a/presentation/Christopher_Lopez_Capstone_Business_Facing_Presentation.pptx
+++ b/presentation/Christopher_Lopez_Capstone_Business_Facing_Presentation.pptx
@@ -1715,7 +1715,7 @@
                 <a:ea typeface="Calibri" pitchFamily="34" charset="-122"/>
                 <a:cs typeface="Calibri" pitchFamily="34" charset="-120"/>
               </a:rPr>
-              <a:t>Capstone Project for the AIM Postgraduate Diploma in AI and Machine Learning – June 2026 – July 2026</a:t>
+              <a:t>Capstone Project for the AIM Postgraduate Diploma in AI and Machine Learning – June 2025 – July 2026</a:t>
             </a:r>
           </a:p>
           <a:p>
@@ -5913,9 +5913,8 @@
                 <a:ea typeface="Calibri" pitchFamily="34" charset="-122"/>
                 <a:cs typeface="Calibri" pitchFamily="34" charset="-120"/>
               </a:rPr>
-              <a:t>4 Behavior</a:t>
-            </a:r>
-            <a:endParaRPr lang="en-US" sz="1300" dirty="0"/>
+              <a:t>3 Machine </a:t>
+            </a:r>
           </a:p>
           <a:p>
             <a:pPr marL="0" indent="0" algn="ctr">
@@ -5930,7 +5929,7 @@
                 <a:ea typeface="Calibri" pitchFamily="34" charset="-122"/>
                 <a:cs typeface="Calibri" pitchFamily="34" charset="-120"/>
               </a:rPr>
-              <a:t>Groups</a:t>
+              <a:t>States</a:t>
             </a:r>
             <a:endParaRPr lang="en-US" sz="1300" dirty="0"/>
           </a:p>

</xml_diff>